<commit_message>
Add the two extensions to the deck (adaptive exposure + agent simulation)
The extensions are the project's contribution beyond the paper, so they get two
dedicated "Beyond the paper" slides in docs/RWE_talk.pptx (24 slides now), each
with a result diagram:

- docs/make_diagrams.py: two new figures generated from live results --
  adaptive_exposure.png (fixed RWE-B flips everyone vs AdaptiveRWEB's calibrated
  0.05 / 0.52 dose for low/high-tolerance users) and alpha_sweep.png
  (satisfaction falls monotonically as confirmation bias rises).
- docs/make_deck.py: two slides before the wrap-up mapping to satisfaction.py
  and agent_sim.py; "This implementation" updated (7 diagrams).

Verified: 24 slides, no long bullets, no image overflow; new slides rendered
and inspected.

Co-Authored-By: Claude Opus 4.8 <noreply@anthropic.com>
Claude-Session: https://claude.ai/code/session_01DcTtyhsBxwWfFmVRuFUaej
</commit_message>
<xml_diff>
--- a/docs/RWE_talk.pptx
+++ b/docs/RWE_talk.pptx
@@ -27,6 +27,8 @@
     <p:sldId id="275" r:id="rId27"/>
     <p:sldId id="276" r:id="rId28"/>
     <p:sldId id="277" r:id="rId29"/>
+    <p:sldId id="278" r:id="rId30"/>
+    <p:sldId id="279" r:id="rId31"/>
   </p:sldIdLst>
   <p:sldSz cx="12191695" cy="6858000" type="screen4x3"/>
   <p:notesSz cx="6858000" cy="9144000"/>
@@ -1433,7 +1435,7 @@
           <a:lstStyle/>
           <a:p>
             <a:r>
-              <a:t>What this repository adds on top of the paper.</a:t>
+              <a:t>A fixed aggressive strategy flips every user; the adaptive version protects low-tolerance users while still bridging high-tolerance ones.</a:t>
             </a:r>
           </a:p>
         </p:txBody>
@@ -1459,6 +1461,146 @@
 </file>
 
 <file path=ppt/notesSlides/notesSlide22.xml><?xml version="1.0" encoding="utf-8"?>
+<p:notes xmlns:a="http://schemas.openxmlformats.org/drawingml/2006/main" xmlns:p="http://schemas.openxmlformats.org/presentationml/2006/main" xmlns:r="http://schemas.openxmlformats.org/officeDocument/2006/relationships">
+  <p:cSld>
+    <p:spTree>
+      <p:nvGrpSpPr>
+        <p:cNvPr id="1" name=""/>
+        <p:cNvGrpSpPr/>
+        <p:nvPr/>
+      </p:nvGrpSpPr>
+      <p:grpSpPr>
+        <a:xfrm>
+          <a:off x="0" y="0"/>
+          <a:ext cx="0" cy="0"/>
+          <a:chOff x="0" y="0"/>
+          <a:chExt cx="0" cy="0"/>
+        </a:xfrm>
+      </p:grpSpPr>
+      <p:sp>
+        <p:nvSpPr>
+          <p:cNvPr id="2" name="Slide Image Placeholder 1"/>
+          <p:cNvSpPr>
+            <a:spLocks noGrp="1"/>
+          </p:cNvSpPr>
+          <p:nvPr>
+            <p:ph type="sldImg" idx="2"/>
+          </p:nvPr>
+        </p:nvSpPr>
+        <p:spPr/>
+      </p:sp>
+      <p:sp>
+        <p:nvSpPr>
+          <p:cNvPr id="3" name="Notes Placeholder 2"/>
+          <p:cNvSpPr>
+            <a:spLocks noGrp="1"/>
+          </p:cNvSpPr>
+          <p:nvPr>
+            <p:ph type="body" idx="3" sz="quarter"/>
+          </p:nvPr>
+        </p:nvSpPr>
+        <p:spPr/>
+        <p:txBody>
+          <a:bodyPr/>
+          <a:lstStyle/>
+          <a:p>
+            <a:r>
+              <a:t>α-sweep validation: mean satisfaction falls monotonically as confirmation bias rises.</a:t>
+            </a:r>
+          </a:p>
+        </p:txBody>
+      </p:sp>
+      <p:sp>
+        <p:nvSpPr>
+          <p:cNvPr id="4" name="Slide Number Placeholder 3"/>
+          <p:cNvSpPr>
+            <a:spLocks noGrp="1"/>
+          </p:cNvSpPr>
+          <p:nvPr>
+            <p:ph type="sldNum" idx="5" sz="quarter"/>
+          </p:nvPr>
+        </p:nvSpPr>
+        <p:spPr/>
+      </p:sp>
+    </p:spTree>
+  </p:cSld>
+  <p:clrMapOvr>
+    <a:masterClrMapping/>
+  </p:clrMapOvr>
+</p:notes>
+</file>
+
+<file path=ppt/notesSlides/notesSlide23.xml><?xml version="1.0" encoding="utf-8"?>
+<p:notes xmlns:a="http://schemas.openxmlformats.org/drawingml/2006/main" xmlns:p="http://schemas.openxmlformats.org/presentationml/2006/main" xmlns:r="http://schemas.openxmlformats.org/officeDocument/2006/relationships">
+  <p:cSld>
+    <p:spTree>
+      <p:nvGrpSpPr>
+        <p:cNvPr id="1" name=""/>
+        <p:cNvGrpSpPr/>
+        <p:nvPr/>
+      </p:nvGrpSpPr>
+      <p:grpSpPr>
+        <a:xfrm>
+          <a:off x="0" y="0"/>
+          <a:ext cx="0" cy="0"/>
+          <a:chOff x="0" y="0"/>
+          <a:chExt cx="0" cy="0"/>
+        </a:xfrm>
+      </p:grpSpPr>
+      <p:sp>
+        <p:nvSpPr>
+          <p:cNvPr id="2" name="Slide Image Placeholder 1"/>
+          <p:cNvSpPr>
+            <a:spLocks noGrp="1"/>
+          </p:cNvSpPr>
+          <p:nvPr>
+            <p:ph type="sldImg" idx="2"/>
+          </p:nvPr>
+        </p:nvSpPr>
+        <p:spPr/>
+      </p:sp>
+      <p:sp>
+        <p:nvSpPr>
+          <p:cNvPr id="3" name="Notes Placeholder 2"/>
+          <p:cNvSpPr>
+            <a:spLocks noGrp="1"/>
+          </p:cNvSpPr>
+          <p:nvPr>
+            <p:ph type="body" idx="3" sz="quarter"/>
+          </p:nvPr>
+        </p:nvSpPr>
+        <p:spPr/>
+        <p:txBody>
+          <a:bodyPr/>
+          <a:lstStyle/>
+          <a:p>
+            <a:r>
+              <a:t>What this repository adds on top of the paper.</a:t>
+            </a:r>
+          </a:p>
+        </p:txBody>
+      </p:sp>
+      <p:sp>
+        <p:nvSpPr>
+          <p:cNvPr id="4" name="Slide Number Placeholder 3"/>
+          <p:cNvSpPr>
+            <a:spLocks noGrp="1"/>
+          </p:cNvSpPr>
+          <p:nvPr>
+            <p:ph type="sldNum" idx="5" sz="quarter"/>
+          </p:nvPr>
+        </p:nvSpPr>
+        <p:spPr/>
+      </p:sp>
+    </p:spTree>
+  </p:cSld>
+  <p:clrMapOvr>
+    <a:masterClrMapping/>
+  </p:clrMapOvr>
+</p:notes>
+</file>
+
+<file path=ppt/notesSlides/notesSlide24.xml><?xml version="1.0" encoding="utf-8"?>
 <p:notes xmlns:a="http://schemas.openxmlformats.org/drawingml/2006/main" xmlns:p="http://schemas.openxmlformats.org/presentationml/2006/main" xmlns:r="http://schemas.openxmlformats.org/officeDocument/2006/relationships">
   <p:cSld>
     <p:spTree>
@@ -8018,7 +8160,7 @@
                   <a:srgbClr val="8B1A1A"/>
                 </a:solidFill>
               </a:rPr>
-              <a:t>This implementation</a:t>
+              <a:t>Beyond the paper — adaptive exposure</a:t>
             </a:r>
           </a:p>
         </p:txBody>
@@ -8076,7 +8218,7 @@
         <p:spPr>
           <a:xfrm>
             <a:off x="548640" y="1417320"/>
-            <a:ext cx="11094415" cy="4206240"/>
+            <a:ext cx="11094415" cy="1280160"/>
           </a:xfrm>
           <a:prstGeom prst="rect">
             <a:avLst/>
@@ -8100,7 +8242,7 @@
                   <a:srgbClr val="333333"/>
                 </a:solidFill>
               </a:rPr>
-              <a:t>•  Full paper in rwe/ (graph, RWE, ideology, baselines, metrics) + 2 extensions.</a:t>
+              <a:t>•  Our extension: tailor how much opposing content each user sees.</a:t>
             </a:r>
           </a:p>
           <a:p>
@@ -8115,7 +8257,7 @@
                   <a:srgbClr val="333333"/>
                 </a:solidFill>
               </a:rPr>
-              <a:t>•  63 tests — including the worked erasure example reproduced to the decimal.</a:t>
+              <a:t>•  Satisfaction score = pages read in the first opposing community before exiting.</a:t>
             </a:r>
           </a:p>
           <a:p>
@@ -8130,29 +8272,38 @@
                   <a:srgbClr val="333333"/>
                 </a:solidFill>
               </a:rPr>
-              <a:t>•  5 diagrams, a beginner guide (GUIDE.md), and a slide-by-slide map (docs/TALK.md).</a:t>
-            </a:r>
-          </a:p>
-          <a:p>
-            <a:pPr>
-              <a:spcAft>
-                <a:spcPts val="700"/>
-              </a:spcAft>
-            </a:pPr>
-            <a:r>
-              <a:rPr sz="1900">
-                <a:solidFill>
-                  <a:srgbClr val="333333"/>
-                </a:solidFill>
-              </a:rPr>
-              <a:t>•  Run:  pip install -e .   ·   pytest -q   ·   python examples/demo_synthetic.py</a:t>
-            </a:r>
-          </a:p>
-        </p:txBody>
-      </p:sp>
-      <p:sp>
-        <p:nvSpPr>
-          <p:cNvPr id="5" name="Rounded Rectangle 4"/>
+              <a:t>•  Higher tolerance → more opposing content surfaced (AdaptiveRWEB).</a:t>
+            </a:r>
+          </a:p>
+        </p:txBody>
+      </p:sp>
+      <p:pic>
+        <p:nvPicPr>
+          <p:cNvPr id="5" name="Picture 4" descr="adaptive_exposure.png"/>
+          <p:cNvPicPr>
+            <a:picLocks noChangeAspect="1"/>
+          </p:cNvPicPr>
+          <p:nvPr/>
+        </p:nvPicPr>
+        <p:blipFill>
+          <a:blip r:embed="rId2"/>
+          <a:stretch>
+            <a:fillRect/>
+          </a:stretch>
+        </p:blipFill>
+        <p:spPr>
+          <a:xfrm>
+            <a:off x="4023259" y="3063239"/>
+            <a:ext cx="4145175" cy="2788920"/>
+          </a:xfrm>
+          <a:prstGeom prst="rect">
+            <a:avLst/>
+          </a:prstGeom>
+        </p:spPr>
+      </p:pic>
+      <p:sp>
+        <p:nvSpPr>
+          <p:cNvPr id="6" name="Rounded Rectangle 5"/>
           <p:cNvSpPr/>
           <p:nvPr/>
         </p:nvSpPr>
@@ -8207,7 +8358,7 @@
                   <a:srgbClr val="333333"/>
                 </a:solidFill>
               </a:rPr>
-              <a:t>github: greenwichg/random_walks_with_erasure</a:t>
+              <a:t>rwe/satisfaction.py: WebGraph · SatisfactionModel · AdaptiveRWEB</a:t>
             </a:r>
           </a:p>
         </p:txBody>
@@ -8221,6 +8372,495 @@
 </file>
 
 <file path=ppt/slides/slide22.xml><?xml version="1.0" encoding="utf-8"?>
+<p:sld xmlns:a="http://schemas.openxmlformats.org/drawingml/2006/main" xmlns:p="http://schemas.openxmlformats.org/presentationml/2006/main" xmlns:r="http://schemas.openxmlformats.org/officeDocument/2006/relationships">
+  <p:cSld>
+    <p:spTree>
+      <p:nvGrpSpPr>
+        <p:cNvPr id="1" name=""/>
+        <p:cNvGrpSpPr/>
+        <p:nvPr/>
+      </p:nvGrpSpPr>
+      <p:grpSpPr/>
+      <p:sp>
+        <p:nvSpPr>
+          <p:cNvPr id="2" name="TextBox 1"/>
+          <p:cNvSpPr txBox="1"/>
+          <p:nvPr/>
+        </p:nvSpPr>
+        <p:spPr>
+          <a:xfrm>
+            <a:off x="548640" y="274320"/>
+            <a:ext cx="11094415" cy="868680"/>
+          </a:xfrm>
+          <a:prstGeom prst="rect">
+            <a:avLst/>
+          </a:prstGeom>
+          <a:noFill/>
+        </p:spPr>
+        <p:txBody>
+          <a:bodyPr wrap="square">
+            <a:spAutoFit/>
+          </a:bodyPr>
+          <a:lstStyle/>
+          <a:p>
+            <a:r>
+              <a:rPr sz="3000" b="1">
+                <a:solidFill>
+                  <a:srgbClr val="8B1A1A"/>
+                </a:solidFill>
+              </a:rPr>
+              <a:t>Beyond the paper — agent browsing simulation</a:t>
+            </a:r>
+          </a:p>
+        </p:txBody>
+      </p:sp>
+      <p:sp>
+        <p:nvSpPr>
+          <p:cNvPr id="3" name="Rectangle 2"/>
+          <p:cNvSpPr/>
+          <p:nvPr/>
+        </p:nvSpPr>
+        <p:spPr>
+          <a:xfrm>
+            <a:off x="548640" y="1170432"/>
+            <a:ext cx="11094415" cy="25400"/>
+          </a:xfrm>
+          <a:prstGeom prst="rect">
+            <a:avLst/>
+          </a:prstGeom>
+          <a:solidFill>
+            <a:srgbClr val="CCCCCC"/>
+          </a:solidFill>
+          <a:ln>
+            <a:noFill/>
+          </a:ln>
+          <a:effectLst/>
+        </p:spPr>
+        <p:style>
+          <a:lnRef idx="1">
+            <a:schemeClr val="accent1"/>
+          </a:lnRef>
+          <a:fillRef idx="3">
+            <a:schemeClr val="accent1"/>
+          </a:fillRef>
+          <a:effectRef idx="2">
+            <a:schemeClr val="accent1"/>
+          </a:effectRef>
+          <a:fontRef idx="minor">
+            <a:schemeClr val="lt1"/>
+          </a:fontRef>
+        </p:style>
+        <p:txBody>
+          <a:bodyPr rtlCol="0" anchor="ctr"/>
+          <a:lstStyle/>
+          <a:p>
+            <a:pPr algn="ctr"/>
+          </a:p>
+        </p:txBody>
+      </p:sp>
+      <p:sp>
+        <p:nvSpPr>
+          <p:cNvPr id="4" name="TextBox 3"/>
+          <p:cNvSpPr txBox="1"/>
+          <p:nvPr/>
+        </p:nvSpPr>
+        <p:spPr>
+          <a:xfrm>
+            <a:off x="548640" y="1417320"/>
+            <a:ext cx="11094415" cy="1280160"/>
+          </a:xfrm>
+          <a:prstGeom prst="rect">
+            <a:avLst/>
+          </a:prstGeom>
+          <a:noFill/>
+        </p:spPr>
+        <p:txBody>
+          <a:bodyPr wrap="square">
+            <a:spAutoFit/>
+          </a:bodyPr>
+          <a:lstStyle/>
+          <a:p>
+            <a:pPr>
+              <a:spcAft>
+                <a:spcPts val="700"/>
+              </a:spcAft>
+            </a:pPr>
+            <a:r>
+              <a:rPr sz="1900">
+                <a:solidFill>
+                  <a:srgbClr val="333333"/>
+                </a:solidFill>
+              </a:rPr>
+              <a:t>•  Agent-based model on a networkx web graph (Louvain/Leiden communities).</a:t>
+            </a:r>
+          </a:p>
+          <a:p>
+            <a:pPr>
+              <a:spcAft>
+                <a:spcPts val="700"/>
+              </a:spcAft>
+            </a:pPr>
+            <a:r>
+              <a:rPr sz="1900">
+                <a:solidFill>
+                  <a:srgbClr val="333333"/>
+                </a:solidFill>
+              </a:rPr>
+              <a:t>•  State machine: own side → first opposite page → track → exit.</a:t>
+            </a:r>
+          </a:p>
+          <a:p>
+            <a:pPr>
+              <a:spcAft>
+                <a:spcPts val="700"/>
+              </a:spcAft>
+            </a:pPr>
+            <a:r>
+              <a:rPr sz="1900">
+                <a:solidFill>
+                  <a:srgbClr val="333333"/>
+                </a:solidFill>
+              </a:rPr>
+              <a:t>•  Tunable α: confirmation bias (α&gt;0) vs "rabbit hole" (α&lt;0); Monte-Carlo scores.</a:t>
+            </a:r>
+          </a:p>
+        </p:txBody>
+      </p:sp>
+      <p:pic>
+        <p:nvPicPr>
+          <p:cNvPr id="5" name="Picture 4" descr="alpha_sweep.png"/>
+          <p:cNvPicPr>
+            <a:picLocks noChangeAspect="1"/>
+          </p:cNvPicPr>
+          <p:nvPr/>
+        </p:nvPicPr>
+        <p:blipFill>
+          <a:blip r:embed="rId2"/>
+          <a:stretch>
+            <a:fillRect/>
+          </a:stretch>
+        </p:blipFill>
+        <p:spPr>
+          <a:xfrm>
+            <a:off x="3862225" y="3063240"/>
+            <a:ext cx="4467244" cy="2788919"/>
+          </a:xfrm>
+          <a:prstGeom prst="rect">
+            <a:avLst/>
+          </a:prstGeom>
+        </p:spPr>
+      </p:pic>
+      <p:sp>
+        <p:nvSpPr>
+          <p:cNvPr id="6" name="Rounded Rectangle 5"/>
+          <p:cNvSpPr/>
+          <p:nvPr/>
+        </p:nvSpPr>
+        <p:spPr>
+          <a:xfrm>
+            <a:off x="548640" y="5989320"/>
+            <a:ext cx="11094415" cy="566928"/>
+          </a:xfrm>
+          <a:prstGeom prst="roundRect">
+            <a:avLst/>
+          </a:prstGeom>
+          <a:solidFill>
+            <a:srgbClr val="EEF5EE"/>
+          </a:solidFill>
+          <a:ln w="9525">
+            <a:solidFill>
+              <a:srgbClr val="55A868"/>
+            </a:solidFill>
+          </a:ln>
+          <a:effectLst/>
+        </p:spPr>
+        <p:style>
+          <a:lnRef idx="1">
+            <a:schemeClr val="accent1"/>
+          </a:lnRef>
+          <a:fillRef idx="3">
+            <a:schemeClr val="accent1"/>
+          </a:fillRef>
+          <a:effectRef idx="2">
+            <a:schemeClr val="accent1"/>
+          </a:effectRef>
+          <a:fontRef idx="minor">
+            <a:schemeClr val="lt1"/>
+          </a:fontRef>
+        </p:style>
+        <p:txBody>
+          <a:bodyPr rtlCol="0" anchor="ctr" wrap="square" tIns="25400" bIns="25400"/>
+          <a:lstStyle/>
+          <a:p>
+            <a:pPr algn="ctr"/>
+            <a:r>
+              <a:rPr sz="1300" b="1">
+                <a:solidFill>
+                  <a:srgbClr val="2E6B3E"/>
+                </a:solidFill>
+              </a:rPr>
+              <a:t>→ In the code:  </a:t>
+            </a:r>
+            <a:r>
+              <a:rPr sz="1300">
+                <a:solidFill>
+                  <a:srgbClr val="333333"/>
+                </a:solidFill>
+              </a:rPr>
+              <a:t>rwe/agent_sim.py: NewsfeedSimulator · monte_carlo · alpha_sweep</a:t>
+            </a:r>
+          </a:p>
+        </p:txBody>
+      </p:sp>
+    </p:spTree>
+  </p:cSld>
+  <p:clrMapOvr>
+    <a:masterClrMapping/>
+  </p:clrMapOvr>
+</p:sld>
+</file>
+
+<file path=ppt/slides/slide23.xml><?xml version="1.0" encoding="utf-8"?>
+<p:sld xmlns:a="http://schemas.openxmlformats.org/drawingml/2006/main" xmlns:p="http://schemas.openxmlformats.org/presentationml/2006/main" xmlns:r="http://schemas.openxmlformats.org/officeDocument/2006/relationships">
+  <p:cSld>
+    <p:spTree>
+      <p:nvGrpSpPr>
+        <p:cNvPr id="1" name=""/>
+        <p:cNvGrpSpPr/>
+        <p:nvPr/>
+      </p:nvGrpSpPr>
+      <p:grpSpPr/>
+      <p:sp>
+        <p:nvSpPr>
+          <p:cNvPr id="2" name="TextBox 1"/>
+          <p:cNvSpPr txBox="1"/>
+          <p:nvPr/>
+        </p:nvSpPr>
+        <p:spPr>
+          <a:xfrm>
+            <a:off x="548640" y="274320"/>
+            <a:ext cx="11094415" cy="868680"/>
+          </a:xfrm>
+          <a:prstGeom prst="rect">
+            <a:avLst/>
+          </a:prstGeom>
+          <a:noFill/>
+        </p:spPr>
+        <p:txBody>
+          <a:bodyPr wrap="square">
+            <a:spAutoFit/>
+          </a:bodyPr>
+          <a:lstStyle/>
+          <a:p>
+            <a:r>
+              <a:rPr sz="3000" b="1">
+                <a:solidFill>
+                  <a:srgbClr val="8B1A1A"/>
+                </a:solidFill>
+              </a:rPr>
+              <a:t>This implementation</a:t>
+            </a:r>
+          </a:p>
+        </p:txBody>
+      </p:sp>
+      <p:sp>
+        <p:nvSpPr>
+          <p:cNvPr id="3" name="Rectangle 2"/>
+          <p:cNvSpPr/>
+          <p:nvPr/>
+        </p:nvSpPr>
+        <p:spPr>
+          <a:xfrm>
+            <a:off x="548640" y="1170432"/>
+            <a:ext cx="11094415" cy="25400"/>
+          </a:xfrm>
+          <a:prstGeom prst="rect">
+            <a:avLst/>
+          </a:prstGeom>
+          <a:solidFill>
+            <a:srgbClr val="CCCCCC"/>
+          </a:solidFill>
+          <a:ln>
+            <a:noFill/>
+          </a:ln>
+          <a:effectLst/>
+        </p:spPr>
+        <p:style>
+          <a:lnRef idx="1">
+            <a:schemeClr val="accent1"/>
+          </a:lnRef>
+          <a:fillRef idx="3">
+            <a:schemeClr val="accent1"/>
+          </a:fillRef>
+          <a:effectRef idx="2">
+            <a:schemeClr val="accent1"/>
+          </a:effectRef>
+          <a:fontRef idx="minor">
+            <a:schemeClr val="lt1"/>
+          </a:fontRef>
+        </p:style>
+        <p:txBody>
+          <a:bodyPr rtlCol="0" anchor="ctr"/>
+          <a:lstStyle/>
+          <a:p>
+            <a:pPr algn="ctr"/>
+          </a:p>
+        </p:txBody>
+      </p:sp>
+      <p:sp>
+        <p:nvSpPr>
+          <p:cNvPr id="4" name="TextBox 3"/>
+          <p:cNvSpPr txBox="1"/>
+          <p:nvPr/>
+        </p:nvSpPr>
+        <p:spPr>
+          <a:xfrm>
+            <a:off x="548640" y="1417320"/>
+            <a:ext cx="11094415" cy="4206240"/>
+          </a:xfrm>
+          <a:prstGeom prst="rect">
+            <a:avLst/>
+          </a:prstGeom>
+          <a:noFill/>
+        </p:spPr>
+        <p:txBody>
+          <a:bodyPr wrap="square">
+            <a:spAutoFit/>
+          </a:bodyPr>
+          <a:lstStyle/>
+          <a:p>
+            <a:pPr>
+              <a:spcAft>
+                <a:spcPts val="700"/>
+              </a:spcAft>
+            </a:pPr>
+            <a:r>
+              <a:rPr sz="1900">
+                <a:solidFill>
+                  <a:srgbClr val="333333"/>
+                </a:solidFill>
+              </a:rPr>
+              <a:t>•  Full paper in rwe/ (graph, RWE, ideology, baselines, metrics) + 2 extensions.</a:t>
+            </a:r>
+          </a:p>
+          <a:p>
+            <a:pPr>
+              <a:spcAft>
+                <a:spcPts val="700"/>
+              </a:spcAft>
+            </a:pPr>
+            <a:r>
+              <a:rPr sz="1900">
+                <a:solidFill>
+                  <a:srgbClr val="333333"/>
+                </a:solidFill>
+              </a:rPr>
+              <a:t>•  63 tests — including the worked erasure example reproduced to the decimal.</a:t>
+            </a:r>
+          </a:p>
+          <a:p>
+            <a:pPr>
+              <a:spcAft>
+                <a:spcPts val="700"/>
+              </a:spcAft>
+            </a:pPr>
+            <a:r>
+              <a:rPr sz="1900">
+                <a:solidFill>
+                  <a:srgbClr val="333333"/>
+                </a:solidFill>
+              </a:rPr>
+              <a:t>•  7 diagrams, a beginner guide (GUIDE.md) and a verification report (TALK.md).</a:t>
+            </a:r>
+          </a:p>
+          <a:p>
+            <a:pPr>
+              <a:spcAft>
+                <a:spcPts val="700"/>
+              </a:spcAft>
+            </a:pPr>
+            <a:r>
+              <a:rPr sz="1900">
+                <a:solidFill>
+                  <a:srgbClr val="333333"/>
+                </a:solidFill>
+              </a:rPr>
+              <a:t>•  Run:  pip install -e .   ·   pytest -q   ·   python examples/demo_synthetic.py</a:t>
+            </a:r>
+          </a:p>
+        </p:txBody>
+      </p:sp>
+      <p:sp>
+        <p:nvSpPr>
+          <p:cNvPr id="5" name="Rounded Rectangle 4"/>
+          <p:cNvSpPr/>
+          <p:nvPr/>
+        </p:nvSpPr>
+        <p:spPr>
+          <a:xfrm>
+            <a:off x="548640" y="5989320"/>
+            <a:ext cx="11094415" cy="566928"/>
+          </a:xfrm>
+          <a:prstGeom prst="roundRect">
+            <a:avLst/>
+          </a:prstGeom>
+          <a:solidFill>
+            <a:srgbClr val="EEF5EE"/>
+          </a:solidFill>
+          <a:ln w="9525">
+            <a:solidFill>
+              <a:srgbClr val="55A868"/>
+            </a:solidFill>
+          </a:ln>
+          <a:effectLst/>
+        </p:spPr>
+        <p:style>
+          <a:lnRef idx="1">
+            <a:schemeClr val="accent1"/>
+          </a:lnRef>
+          <a:fillRef idx="3">
+            <a:schemeClr val="accent1"/>
+          </a:fillRef>
+          <a:effectRef idx="2">
+            <a:schemeClr val="accent1"/>
+          </a:effectRef>
+          <a:fontRef idx="minor">
+            <a:schemeClr val="lt1"/>
+          </a:fontRef>
+        </p:style>
+        <p:txBody>
+          <a:bodyPr rtlCol="0" anchor="ctr" wrap="square" tIns="25400" bIns="25400"/>
+          <a:lstStyle/>
+          <a:p>
+            <a:pPr algn="ctr"/>
+            <a:r>
+              <a:rPr sz="1300" b="1">
+                <a:solidFill>
+                  <a:srgbClr val="2E6B3E"/>
+                </a:solidFill>
+              </a:rPr>
+              <a:t>→ In the code:  </a:t>
+            </a:r>
+            <a:r>
+              <a:rPr sz="1300">
+                <a:solidFill>
+                  <a:srgbClr val="333333"/>
+                </a:solidFill>
+              </a:rPr>
+              <a:t>github: greenwichg/random_walks_with_erasure</a:t>
+            </a:r>
+          </a:p>
+        </p:txBody>
+      </p:sp>
+    </p:spTree>
+  </p:cSld>
+  <p:clrMapOvr>
+    <a:masterClrMapping/>
+  </p:clrMapOvr>
+</p:sld>
+</file>
+
+<file path=ppt/slides/slide24.xml><?xml version="1.0" encoding="utf-8"?>
 <p:sld xmlns:a="http://schemas.openxmlformats.org/drawingml/2006/main" xmlns:p="http://schemas.openxmlformats.org/presentationml/2006/main" xmlns:r="http://schemas.openxmlformats.org/officeDocument/2006/relationships">
   <p:cSld>
     <p:spTree>

</xml_diff>

<commit_message>
Refine extension diagrams: synthetic-data note + single alpha-sweep line
Honesty/clarity tweaks to the two extension figures (and the embedding deck):

- adaptive_exposure.png / alpha_sweep.png: add an explicit "synthetic data;
  planted positions (illustrative)" subnote so they aren't read as real-world
  performance numbers.
- alpha_sweep.png: collapse the symmetric left/right agents into one
  representative line (their gap is a random-graph artifact, not a real
  left/right effect), keeping the monotonic-decrease message clean; "rabbit
  hole" / "confirmation bias" annotations added.
- docs/RWE_talk.pptx regenerated with the updated images.

Numbers re-verified before the change: both graphs reproduce exactly and both
curves are strictly monotonic.

Co-Authored-By: Claude Opus 4.8 <noreply@anthropic.com>
Claude-Session: https://claude.ai/code/session_01DcTtyhsBxwWfFmVRuFUaej
</commit_message>
<xml_diff>
--- a/docs/RWE_talk.pptx
+++ b/docs/RWE_talk.pptx
@@ -8293,8 +8293,8 @@
         </p:blipFill>
         <p:spPr>
           <a:xfrm>
-            <a:off x="4023259" y="3063239"/>
-            <a:ext cx="4145175" cy="2788920"/>
+            <a:off x="4151131" y="3063240"/>
+            <a:ext cx="3889432" cy="2788920"/>
           </a:xfrm>
           <a:prstGeom prst="rect">
             <a:avLst/>
@@ -8542,8 +8542,8 @@
         </p:blipFill>
         <p:spPr>
           <a:xfrm>
-            <a:off x="3862225" y="3063240"/>
-            <a:ext cx="4467244" cy="2788919"/>
+            <a:off x="4002215" y="3063239"/>
+            <a:ext cx="4187264" cy="2788920"/>
           </a:xfrm>
           <a:prstGeom prst="rect">
             <a:avLst/>

</xml_diff>

<commit_message>
Declutter the RWE-flow diagram (slide 12)
The middle page boxes were congested: the forward walk arrow and the thick
erased arrow both attached near the box's left edge, and the q=0.9 arrow was a
blob overlapping the box. Redesigned: more S↔box spacing, one clean walk arrow
into each box's left-centre, erased arrows leaving the outer corner in clear
return loops, and capped arrow thickness. Deck and PDF regenerated to embed it.

Co-Authored-By: Claude Opus 4.8 <noreply@anthropic.com>
Claude-Session: https://claude.ai/code/session_01DcTtyhsBxwWfFmVRuFUaej
</commit_message>
<xml_diff>
--- a/docs/RWE_talk.pptx
+++ b/docs/RWE_talk.pptx
@@ -6077,8 +6077,8 @@
         </p:blipFill>
         <p:spPr>
           <a:xfrm>
-            <a:off x="3640812" y="3063240"/>
-            <a:ext cx="4910070" cy="2788920"/>
+            <a:off x="3518094" y="3063240"/>
+            <a:ext cx="5155506" cy="2788919"/>
           </a:xfrm>
           <a:prstGeom prst="rect">
             <a:avLst/>

</xml_diff>

<commit_message>
Make diagram captions/footnotes larger and darker for legibility
The small light-gray italic caption and data-provenance lines under the
charts were hard to read. Bump their font size and darken the color
(new CAP/SUB palette constants) across adaptive_exposure, quadrant_scatter,
alpha_sweep, opinion_dynamics, guardrails, and bipartite_graph; regenerate
the embedded PNGs plus RWE_talk.pptx / RWE_talk.pdf.

Co-Authored-By: Claude Opus 4.8 <noreply@anthropic.com>
Claude-Session: https://claude.ai/code/session_01DcTtyhsBxwWfFmVRuFUaej
</commit_message>
<xml_diff>
--- a/docs/RWE_talk.pptx
+++ b/docs/RWE_talk.pptx
@@ -8435,8 +8435,8 @@
         </p:blipFill>
         <p:spPr>
           <a:xfrm>
-            <a:off x="4151131" y="3063240"/>
-            <a:ext cx="3889432" cy="2788920"/>
+            <a:off x="4036854" y="3063240"/>
+            <a:ext cx="4117987" cy="2788920"/>
           </a:xfrm>
           <a:prstGeom prst="rect">
             <a:avLst/>
@@ -8684,8 +8684,8 @@
         </p:blipFill>
         <p:spPr>
           <a:xfrm>
-            <a:off x="4002215" y="3063239"/>
-            <a:ext cx="4187264" cy="2788920"/>
+            <a:off x="4005127" y="3063240"/>
+            <a:ext cx="4181440" cy="2788920"/>
           </a:xfrm>
           <a:prstGeom prst="rect">
             <a:avLst/>
@@ -8933,8 +8933,8 @@
         </p:blipFill>
         <p:spPr>
           <a:xfrm>
-            <a:off x="3978888" y="3063240"/>
-            <a:ext cx="4233917" cy="2788920"/>
+            <a:off x="3981726" y="3063240"/>
+            <a:ext cx="4228241" cy="2788919"/>
           </a:xfrm>
           <a:prstGeom prst="rect">
             <a:avLst/>

</xml_diff>

<commit_message>
Balance whitespace on sparse text slides (centre + airier type)
Text-only slides with only a few bullets left a large empty band above
the code-note box. Vertically centre the bullet block in the body region
and give it larger, more-spaced type so a short list reads as a deliberate,
airy layout rather than unfinished. Image slides keep their compact top
bullets. make_pdf.py now honours paragraph space_after so the PDF mirrors
the deck's spacing. Regenerate RWE_talk.pptx / RWE_talk.pdf.

Co-Authored-By: Claude Opus 4.8 <noreply@anthropic.com>
Claude-Session: https://claude.ai/code/session_01DcTtyhsBxwWfFmVRuFUaej
</commit_message>
<xml_diff>
--- a/docs/RWE_talk.pptx
+++ b/docs/RWE_talk.pptx
@@ -5497,8 +5497,8 @@
         </p:nvSpPr>
         <p:spPr>
           <a:xfrm>
-            <a:off x="548640" y="1417320"/>
-            <a:ext cx="11094415" cy="4206240"/>
+            <a:off x="548640" y="2190115"/>
+            <a:ext cx="11094415" cy="3616324"/>
           </a:xfrm>
           <a:prstGeom prst="rect">
             <a:avLst/>
@@ -5513,11 +5513,11 @@
           <a:p>
             <a:pPr>
               <a:spcAft>
-                <a:spcPts val="700"/>
+                <a:spcPts val="1400"/>
               </a:spcAft>
             </a:pPr>
             <a:r>
-              <a:rPr sz="1900">
+              <a:rPr sz="2100">
                 <a:solidFill>
                   <a:srgbClr val="333333"/>
                 </a:solidFill>
@@ -5528,11 +5528,11 @@
           <a:p>
             <a:pPr>
               <a:spcAft>
-                <a:spcPts val="700"/>
+                <a:spcPts val="1400"/>
               </a:spcAft>
             </a:pPr>
             <a:r>
-              <a:rPr sz="1700">
+              <a:rPr sz="1900">
                 <a:solidFill>
                   <a:srgbClr val="666666"/>
                 </a:solidFill>
@@ -5543,11 +5543,11 @@
           <a:p>
             <a:pPr>
               <a:spcAft>
-                <a:spcPts val="700"/>
+                <a:spcPts val="1400"/>
               </a:spcAft>
             </a:pPr>
             <a:r>
-              <a:rPr sz="1700">
+              <a:rPr sz="1900">
                 <a:solidFill>
                   <a:srgbClr val="666666"/>
                 </a:solidFill>
@@ -5558,11 +5558,11 @@
           <a:p>
             <a:pPr>
               <a:spcAft>
-                <a:spcPts val="700"/>
+                <a:spcPts val="1400"/>
               </a:spcAft>
             </a:pPr>
             <a:r>
-              <a:rPr sz="1700">
+              <a:rPr sz="1900">
                 <a:solidFill>
                   <a:srgbClr val="666666"/>
                 </a:solidFill>
@@ -5573,11 +5573,11 @@
           <a:p>
             <a:pPr>
               <a:spcAft>
-                <a:spcPts val="700"/>
+                <a:spcPts val="1400"/>
               </a:spcAft>
             </a:pPr>
             <a:r>
-              <a:rPr sz="1900">
+              <a:rPr sz="2100">
                 <a:solidFill>
                   <a:srgbClr val="333333"/>
                 </a:solidFill>
@@ -6250,8 +6250,8 @@
         </p:nvSpPr>
         <p:spPr>
           <a:xfrm>
-            <a:off x="548640" y="1417320"/>
-            <a:ext cx="11094415" cy="4206240"/>
+            <a:off x="548640" y="2479040"/>
+            <a:ext cx="11094415" cy="3327399"/>
           </a:xfrm>
           <a:prstGeom prst="rect">
             <a:avLst/>
@@ -6266,11 +6266,11 @@
           <a:p>
             <a:pPr>
               <a:spcAft>
-                <a:spcPts val="700"/>
+                <a:spcPts val="1400"/>
               </a:spcAft>
             </a:pPr>
             <a:r>
-              <a:rPr sz="1900">
+              <a:rPr sz="2100">
                 <a:solidFill>
                   <a:srgbClr val="333333"/>
                 </a:solidFill>
@@ -6281,11 +6281,11 @@
           <a:p>
             <a:pPr>
               <a:spcAft>
-                <a:spcPts val="700"/>
+                <a:spcPts val="1400"/>
               </a:spcAft>
             </a:pPr>
             <a:r>
-              <a:rPr sz="1900">
+              <a:rPr sz="2100">
                 <a:solidFill>
                   <a:srgbClr val="333333"/>
                 </a:solidFill>
@@ -6296,11 +6296,11 @@
           <a:p>
             <a:pPr>
               <a:spcAft>
-                <a:spcPts val="700"/>
+                <a:spcPts val="1400"/>
               </a:spcAft>
             </a:pPr>
             <a:r>
-              <a:rPr sz="1900">
+              <a:rPr sz="2100">
                 <a:solidFill>
                   <a:srgbClr val="333333"/>
                 </a:solidFill>
@@ -6311,11 +6311,11 @@
           <a:p>
             <a:pPr>
               <a:spcAft>
-                <a:spcPts val="700"/>
+                <a:spcPts val="1400"/>
               </a:spcAft>
             </a:pPr>
             <a:r>
-              <a:rPr sz="1900">
+              <a:rPr sz="2100">
                 <a:solidFill>
                   <a:srgbClr val="333333"/>
                 </a:solidFill>
@@ -6490,8 +6490,8 @@
         </p:nvSpPr>
         <p:spPr>
           <a:xfrm>
-            <a:off x="548640" y="1417320"/>
-            <a:ext cx="11094415" cy="4206240"/>
+            <a:off x="548640" y="2767965"/>
+            <a:ext cx="11094415" cy="3038474"/>
           </a:xfrm>
           <a:prstGeom prst="rect">
             <a:avLst/>
@@ -6506,11 +6506,11 @@
           <a:p>
             <a:pPr>
               <a:spcAft>
-                <a:spcPts val="700"/>
+                <a:spcPts val="1400"/>
               </a:spcAft>
             </a:pPr>
             <a:r>
-              <a:rPr sz="1900">
+              <a:rPr sz="2100">
                 <a:solidFill>
                   <a:srgbClr val="333333"/>
                 </a:solidFill>
@@ -6521,11 +6521,11 @@
           <a:p>
             <a:pPr>
               <a:spcAft>
-                <a:spcPts val="700"/>
+                <a:spcPts val="1400"/>
               </a:spcAft>
             </a:pPr>
             <a:r>
-              <a:rPr sz="1900">
+              <a:rPr sz="2100">
                 <a:solidFill>
                   <a:srgbClr val="333333"/>
                 </a:solidFill>
@@ -6536,11 +6536,11 @@
           <a:p>
             <a:pPr>
               <a:spcAft>
-                <a:spcPts val="700"/>
+                <a:spcPts val="1400"/>
               </a:spcAft>
             </a:pPr>
             <a:r>
-              <a:rPr sz="1900">
+              <a:rPr sz="2100">
                 <a:solidFill>
                   <a:srgbClr val="333333"/>
                 </a:solidFill>
@@ -6715,8 +6715,8 @@
         </p:nvSpPr>
         <p:spPr>
           <a:xfrm>
-            <a:off x="548640" y="1417320"/>
-            <a:ext cx="11094415" cy="4206240"/>
+            <a:off x="548640" y="2479040"/>
+            <a:ext cx="11094415" cy="3327399"/>
           </a:xfrm>
           <a:prstGeom prst="rect">
             <a:avLst/>
@@ -6731,11 +6731,11 @@
           <a:p>
             <a:pPr>
               <a:spcAft>
-                <a:spcPts val="700"/>
+                <a:spcPts val="1400"/>
               </a:spcAft>
             </a:pPr>
             <a:r>
-              <a:rPr sz="1900">
+              <a:rPr sz="2100">
                 <a:solidFill>
                   <a:srgbClr val="333333"/>
                 </a:solidFill>
@@ -6746,11 +6746,11 @@
           <a:p>
             <a:pPr>
               <a:spcAft>
-                <a:spcPts val="700"/>
+                <a:spcPts val="1400"/>
               </a:spcAft>
             </a:pPr>
             <a:r>
-              <a:rPr sz="1900">
+              <a:rPr sz="2100">
                 <a:solidFill>
                   <a:srgbClr val="333333"/>
                 </a:solidFill>
@@ -6761,11 +6761,11 @@
           <a:p>
             <a:pPr>
               <a:spcAft>
-                <a:spcPts val="700"/>
+                <a:spcPts val="1400"/>
               </a:spcAft>
             </a:pPr>
             <a:r>
-              <a:rPr sz="1900">
+              <a:rPr sz="2100">
                 <a:solidFill>
                   <a:srgbClr val="333333"/>
                 </a:solidFill>
@@ -6776,11 +6776,11 @@
           <a:p>
             <a:pPr>
               <a:spcAft>
-                <a:spcPts val="700"/>
+                <a:spcPts val="1400"/>
               </a:spcAft>
             </a:pPr>
             <a:r>
-              <a:rPr sz="1700">
+              <a:rPr sz="1900">
                 <a:solidFill>
                   <a:srgbClr val="666666"/>
                 </a:solidFill>
@@ -6955,8 +6955,8 @@
         </p:nvSpPr>
         <p:spPr>
           <a:xfrm>
-            <a:off x="548640" y="1417320"/>
-            <a:ext cx="11094415" cy="4206240"/>
+            <a:off x="548640" y="2767965"/>
+            <a:ext cx="11094415" cy="3038474"/>
           </a:xfrm>
           <a:prstGeom prst="rect">
             <a:avLst/>
@@ -6971,11 +6971,11 @@
           <a:p>
             <a:pPr>
               <a:spcAft>
-                <a:spcPts val="700"/>
+                <a:spcPts val="1400"/>
               </a:spcAft>
             </a:pPr>
             <a:r>
-              <a:rPr sz="1900">
+              <a:rPr sz="2100">
                 <a:solidFill>
                   <a:srgbClr val="333333"/>
                 </a:solidFill>
@@ -6986,11 +6986,11 @@
           <a:p>
             <a:pPr>
               <a:spcAft>
-                <a:spcPts val="700"/>
+                <a:spcPts val="1400"/>
               </a:spcAft>
             </a:pPr>
             <a:r>
-              <a:rPr sz="1900">
+              <a:rPr sz="2100">
                 <a:solidFill>
                   <a:srgbClr val="333333"/>
                 </a:solidFill>
@@ -7001,11 +7001,11 @@
           <a:p>
             <a:pPr>
               <a:spcAft>
-                <a:spcPts val="700"/>
+                <a:spcPts val="1400"/>
               </a:spcAft>
             </a:pPr>
             <a:r>
-              <a:rPr sz="1700">
+              <a:rPr sz="1900">
                 <a:solidFill>
                   <a:srgbClr val="666666"/>
                 </a:solidFill>
@@ -7429,8 +7429,8 @@
         </p:nvSpPr>
         <p:spPr>
           <a:xfrm>
-            <a:off x="548640" y="1417320"/>
-            <a:ext cx="11094415" cy="4206240"/>
+            <a:off x="548640" y="2767965"/>
+            <a:ext cx="11094415" cy="3038474"/>
           </a:xfrm>
           <a:prstGeom prst="rect">
             <a:avLst/>
@@ -7445,11 +7445,11 @@
           <a:p>
             <a:pPr>
               <a:spcAft>
-                <a:spcPts val="700"/>
+                <a:spcPts val="1400"/>
               </a:spcAft>
             </a:pPr>
             <a:r>
-              <a:rPr sz="1900">
+              <a:rPr sz="2100">
                 <a:solidFill>
                   <a:srgbClr val="333333"/>
                 </a:solidFill>
@@ -7460,11 +7460,11 @@
           <a:p>
             <a:pPr>
               <a:spcAft>
-                <a:spcPts val="700"/>
+                <a:spcPts val="1400"/>
               </a:spcAft>
             </a:pPr>
             <a:r>
-              <a:rPr sz="1900">
+              <a:rPr sz="2100">
                 <a:solidFill>
                   <a:srgbClr val="333333"/>
                 </a:solidFill>
@@ -7475,11 +7475,11 @@
           <a:p>
             <a:pPr>
               <a:spcAft>
-                <a:spcPts val="700"/>
+                <a:spcPts val="1400"/>
               </a:spcAft>
             </a:pPr>
             <a:r>
-              <a:rPr sz="1900">
+              <a:rPr sz="2100">
                 <a:solidFill>
                   <a:srgbClr val="333333"/>
                 </a:solidFill>
@@ -7654,8 +7654,8 @@
         </p:nvSpPr>
         <p:spPr>
           <a:xfrm>
-            <a:off x="548640" y="1417320"/>
-            <a:ext cx="11094415" cy="4206240"/>
+            <a:off x="548640" y="2767965"/>
+            <a:ext cx="11094415" cy="3038474"/>
           </a:xfrm>
           <a:prstGeom prst="rect">
             <a:avLst/>
@@ -7670,11 +7670,11 @@
           <a:p>
             <a:pPr>
               <a:spcAft>
-                <a:spcPts val="700"/>
+                <a:spcPts val="1400"/>
               </a:spcAft>
             </a:pPr>
             <a:r>
-              <a:rPr sz="1900">
+              <a:rPr sz="2100">
                 <a:solidFill>
                   <a:srgbClr val="333333"/>
                 </a:solidFill>
@@ -7685,11 +7685,11 @@
           <a:p>
             <a:pPr>
               <a:spcAft>
-                <a:spcPts val="700"/>
+                <a:spcPts val="1400"/>
               </a:spcAft>
             </a:pPr>
             <a:r>
-              <a:rPr sz="1900">
+              <a:rPr sz="2100">
                 <a:solidFill>
                   <a:srgbClr val="333333"/>
                 </a:solidFill>
@@ -7700,11 +7700,11 @@
           <a:p>
             <a:pPr>
               <a:spcAft>
-                <a:spcPts val="700"/>
+                <a:spcPts val="1400"/>
               </a:spcAft>
             </a:pPr>
             <a:r>
-              <a:rPr sz="1900">
+              <a:rPr sz="2100">
                 <a:solidFill>
                   <a:srgbClr val="333333"/>
                 </a:solidFill>
@@ -7879,8 +7879,8 @@
         </p:nvSpPr>
         <p:spPr>
           <a:xfrm>
-            <a:off x="548640" y="1417320"/>
-            <a:ext cx="11094415" cy="4206240"/>
+            <a:off x="548640" y="2479040"/>
+            <a:ext cx="11094415" cy="3327399"/>
           </a:xfrm>
           <a:prstGeom prst="rect">
             <a:avLst/>
@@ -7895,11 +7895,11 @@
           <a:p>
             <a:pPr>
               <a:spcAft>
-                <a:spcPts val="700"/>
+                <a:spcPts val="1400"/>
               </a:spcAft>
             </a:pPr>
             <a:r>
-              <a:rPr sz="1900">
+              <a:rPr sz="2100">
                 <a:solidFill>
                   <a:srgbClr val="333333"/>
                 </a:solidFill>
@@ -7910,11 +7910,11 @@
           <a:p>
             <a:pPr>
               <a:spcAft>
-                <a:spcPts val="700"/>
+                <a:spcPts val="1400"/>
               </a:spcAft>
             </a:pPr>
             <a:r>
-              <a:rPr sz="1900">
+              <a:rPr sz="2100">
                 <a:solidFill>
                   <a:srgbClr val="333333"/>
                 </a:solidFill>
@@ -7925,11 +7925,11 @@
           <a:p>
             <a:pPr>
               <a:spcAft>
-                <a:spcPts val="700"/>
+                <a:spcPts val="1400"/>
               </a:spcAft>
             </a:pPr>
             <a:r>
-              <a:rPr sz="1900">
+              <a:rPr sz="2100">
                 <a:solidFill>
                   <a:srgbClr val="333333"/>
                 </a:solidFill>
@@ -7940,11 +7940,11 @@
           <a:p>
             <a:pPr>
               <a:spcAft>
-                <a:spcPts val="700"/>
+                <a:spcPts val="1400"/>
               </a:spcAft>
             </a:pPr>
             <a:r>
-              <a:rPr sz="1900">
+              <a:rPr sz="2100">
                 <a:solidFill>
                   <a:srgbClr val="333333"/>
                 </a:solidFill>
@@ -8119,8 +8119,8 @@
         </p:nvSpPr>
         <p:spPr>
           <a:xfrm>
-            <a:off x="548640" y="1417320"/>
-            <a:ext cx="11094415" cy="4206240"/>
+            <a:off x="548640" y="2479040"/>
+            <a:ext cx="11094415" cy="3327399"/>
           </a:xfrm>
           <a:prstGeom prst="rect">
             <a:avLst/>
@@ -8135,11 +8135,11 @@
           <a:p>
             <a:pPr>
               <a:spcAft>
-                <a:spcPts val="700"/>
+                <a:spcPts val="1400"/>
               </a:spcAft>
             </a:pPr>
             <a:r>
-              <a:rPr sz="1900">
+              <a:rPr sz="2100">
                 <a:solidFill>
                   <a:srgbClr val="333333"/>
                 </a:solidFill>
@@ -8150,11 +8150,11 @@
           <a:p>
             <a:pPr>
               <a:spcAft>
-                <a:spcPts val="700"/>
+                <a:spcPts val="1400"/>
               </a:spcAft>
             </a:pPr>
             <a:r>
-              <a:rPr sz="1900">
+              <a:rPr sz="2100">
                 <a:solidFill>
                   <a:srgbClr val="333333"/>
                 </a:solidFill>
@@ -8165,11 +8165,11 @@
           <a:p>
             <a:pPr>
               <a:spcAft>
-                <a:spcPts val="700"/>
+                <a:spcPts val="1400"/>
               </a:spcAft>
             </a:pPr>
             <a:r>
-              <a:rPr sz="1900">
+              <a:rPr sz="2100">
                 <a:solidFill>
                   <a:srgbClr val="333333"/>
                 </a:solidFill>
@@ -8180,11 +8180,11 @@
           <a:p>
             <a:pPr>
               <a:spcAft>
-                <a:spcPts val="700"/>
+                <a:spcPts val="1400"/>
               </a:spcAft>
             </a:pPr>
             <a:r>
-              <a:rPr sz="1900">
+              <a:rPr sz="2100">
                 <a:solidFill>
                   <a:srgbClr val="333333"/>
                 </a:solidFill>
@@ -9355,8 +9355,8 @@
         </p:nvSpPr>
         <p:spPr>
           <a:xfrm>
-            <a:off x="548640" y="1417320"/>
-            <a:ext cx="11094415" cy="4206240"/>
+            <a:off x="548640" y="2479040"/>
+            <a:ext cx="11094415" cy="3327399"/>
           </a:xfrm>
           <a:prstGeom prst="rect">
             <a:avLst/>
@@ -9371,11 +9371,11 @@
           <a:p>
             <a:pPr>
               <a:spcAft>
-                <a:spcPts val="700"/>
+                <a:spcPts val="1400"/>
               </a:spcAft>
             </a:pPr>
             <a:r>
-              <a:rPr sz="1900">
+              <a:rPr sz="2100">
                 <a:solidFill>
                   <a:srgbClr val="333333"/>
                 </a:solidFill>
@@ -9386,11 +9386,11 @@
           <a:p>
             <a:pPr>
               <a:spcAft>
-                <a:spcPts val="700"/>
+                <a:spcPts val="1400"/>
               </a:spcAft>
             </a:pPr>
             <a:r>
-              <a:rPr sz="1900">
+              <a:rPr sz="2100">
                 <a:solidFill>
                   <a:srgbClr val="333333"/>
                 </a:solidFill>
@@ -9401,11 +9401,11 @@
           <a:p>
             <a:pPr>
               <a:spcAft>
-                <a:spcPts val="700"/>
+                <a:spcPts val="1400"/>
               </a:spcAft>
             </a:pPr>
             <a:r>
-              <a:rPr sz="1900">
+              <a:rPr sz="2100">
                 <a:solidFill>
                   <a:srgbClr val="333333"/>
                 </a:solidFill>
@@ -9416,11 +9416,11 @@
           <a:p>
             <a:pPr>
               <a:spcAft>
-                <a:spcPts val="700"/>
+                <a:spcPts val="1400"/>
               </a:spcAft>
             </a:pPr>
             <a:r>
-              <a:rPr sz="1900">
+              <a:rPr sz="2100">
                 <a:solidFill>
                   <a:srgbClr val="333333"/>
                 </a:solidFill>
@@ -9595,8 +9595,8 @@
         </p:nvSpPr>
         <p:spPr>
           <a:xfrm>
-            <a:off x="548640" y="1417320"/>
-            <a:ext cx="11094415" cy="4206240"/>
+            <a:off x="548640" y="3042285"/>
+            <a:ext cx="11094415" cy="3312795"/>
           </a:xfrm>
           <a:prstGeom prst="rect">
             <a:avLst/>
@@ -9611,11 +9611,11 @@
           <a:p>
             <a:pPr>
               <a:spcAft>
-                <a:spcPts val="700"/>
+                <a:spcPts val="1400"/>
               </a:spcAft>
             </a:pPr>
             <a:r>
-              <a:rPr sz="1900">
+              <a:rPr sz="2100">
                 <a:solidFill>
                   <a:srgbClr val="333333"/>
                 </a:solidFill>
@@ -9626,11 +9626,11 @@
           <a:p>
             <a:pPr>
               <a:spcAft>
-                <a:spcPts val="700"/>
+                <a:spcPts val="1400"/>
               </a:spcAft>
             </a:pPr>
             <a:r>
-              <a:rPr sz="1900">
+              <a:rPr sz="2100">
                 <a:solidFill>
                   <a:srgbClr val="333333"/>
                 </a:solidFill>
@@ -9641,11 +9641,11 @@
           <a:p>
             <a:pPr>
               <a:spcAft>
-                <a:spcPts val="700"/>
+                <a:spcPts val="1400"/>
               </a:spcAft>
             </a:pPr>
             <a:r>
-              <a:rPr sz="1900">
+              <a:rPr sz="2100">
                 <a:solidFill>
                   <a:srgbClr val="333333"/>
                 </a:solidFill>
@@ -9758,8 +9758,8 @@
         </p:nvSpPr>
         <p:spPr>
           <a:xfrm>
-            <a:off x="548640" y="1417320"/>
-            <a:ext cx="11094415" cy="4206240"/>
+            <a:off x="548640" y="2767965"/>
+            <a:ext cx="11094415" cy="3038474"/>
           </a:xfrm>
           <a:prstGeom prst="rect">
             <a:avLst/>
@@ -9774,11 +9774,11 @@
           <a:p>
             <a:pPr>
               <a:spcAft>
-                <a:spcPts val="700"/>
+                <a:spcPts val="1400"/>
               </a:spcAft>
             </a:pPr>
             <a:r>
-              <a:rPr sz="1900">
+              <a:rPr sz="2100">
                 <a:solidFill>
                   <a:srgbClr val="333333"/>
                 </a:solidFill>
@@ -9789,11 +9789,11 @@
           <a:p>
             <a:pPr>
               <a:spcAft>
-                <a:spcPts val="700"/>
+                <a:spcPts val="1400"/>
               </a:spcAft>
             </a:pPr>
             <a:r>
-              <a:rPr sz="1900">
+              <a:rPr sz="2100">
                 <a:solidFill>
                   <a:srgbClr val="333333"/>
                 </a:solidFill>
@@ -9804,11 +9804,11 @@
           <a:p>
             <a:pPr>
               <a:spcAft>
-                <a:spcPts val="700"/>
+                <a:spcPts val="1400"/>
               </a:spcAft>
             </a:pPr>
             <a:r>
-              <a:rPr sz="1900">
+              <a:rPr sz="2100">
                 <a:solidFill>
                   <a:srgbClr val="333333"/>
                 </a:solidFill>
@@ -9983,8 +9983,8 @@
         </p:nvSpPr>
         <p:spPr>
           <a:xfrm>
-            <a:off x="548640" y="1417320"/>
-            <a:ext cx="11094415" cy="4206240"/>
+            <a:off x="548640" y="2767965"/>
+            <a:ext cx="11094415" cy="3038474"/>
           </a:xfrm>
           <a:prstGeom prst="rect">
             <a:avLst/>
@@ -9999,11 +9999,11 @@
           <a:p>
             <a:pPr>
               <a:spcAft>
-                <a:spcPts val="700"/>
+                <a:spcPts val="1400"/>
               </a:spcAft>
             </a:pPr>
             <a:r>
-              <a:rPr sz="1900">
+              <a:rPr sz="2100">
                 <a:solidFill>
                   <a:srgbClr val="333333"/>
                 </a:solidFill>
@@ -10014,11 +10014,11 @@
           <a:p>
             <a:pPr>
               <a:spcAft>
-                <a:spcPts val="700"/>
+                <a:spcPts val="1400"/>
               </a:spcAft>
             </a:pPr>
             <a:r>
-              <a:rPr sz="1900">
+              <a:rPr sz="2100">
                 <a:solidFill>
                   <a:srgbClr val="333333"/>
                 </a:solidFill>
@@ -10029,11 +10029,11 @@
           <a:p>
             <a:pPr>
               <a:spcAft>
-                <a:spcPts val="700"/>
+                <a:spcPts val="1400"/>
               </a:spcAft>
             </a:pPr>
             <a:r>
-              <a:rPr sz="1900">
+              <a:rPr sz="2100">
                 <a:solidFill>
                   <a:srgbClr val="333333"/>
                 </a:solidFill>
@@ -10208,8 +10208,8 @@
         </p:nvSpPr>
         <p:spPr>
           <a:xfrm>
-            <a:off x="548640" y="1417320"/>
-            <a:ext cx="11094415" cy="4206240"/>
+            <a:off x="548640" y="2767965"/>
+            <a:ext cx="11094415" cy="3038474"/>
           </a:xfrm>
           <a:prstGeom prst="rect">
             <a:avLst/>
@@ -10224,11 +10224,11 @@
           <a:p>
             <a:pPr>
               <a:spcAft>
-                <a:spcPts val="700"/>
+                <a:spcPts val="1400"/>
               </a:spcAft>
             </a:pPr>
             <a:r>
-              <a:rPr sz="1900">
+              <a:rPr sz="2100">
                 <a:solidFill>
                   <a:srgbClr val="333333"/>
                 </a:solidFill>
@@ -10239,11 +10239,11 @@
           <a:p>
             <a:pPr>
               <a:spcAft>
-                <a:spcPts val="700"/>
+                <a:spcPts val="1400"/>
               </a:spcAft>
             </a:pPr>
             <a:r>
-              <a:rPr sz="1900">
+              <a:rPr sz="2100">
                 <a:solidFill>
                   <a:srgbClr val="333333"/>
                 </a:solidFill>
@@ -10254,11 +10254,11 @@
           <a:p>
             <a:pPr>
               <a:spcAft>
-                <a:spcPts val="700"/>
+                <a:spcPts val="1400"/>
               </a:spcAft>
             </a:pPr>
             <a:r>
-              <a:rPr sz="1900">
+              <a:rPr sz="2100">
                 <a:solidFill>
                   <a:srgbClr val="333333"/>
                 </a:solidFill>
@@ -10682,8 +10682,8 @@
         </p:nvSpPr>
         <p:spPr>
           <a:xfrm>
-            <a:off x="548640" y="1417320"/>
-            <a:ext cx="11094415" cy="4206240"/>
+            <a:off x="548640" y="2190115"/>
+            <a:ext cx="11094415" cy="3616324"/>
           </a:xfrm>
           <a:prstGeom prst="rect">
             <a:avLst/>
@@ -10698,11 +10698,11 @@
           <a:p>
             <a:pPr>
               <a:spcAft>
-                <a:spcPts val="700"/>
+                <a:spcPts val="1400"/>
               </a:spcAft>
             </a:pPr>
             <a:r>
-              <a:rPr sz="1900">
+              <a:rPr sz="2100">
                 <a:solidFill>
                   <a:srgbClr val="333333"/>
                 </a:solidFill>
@@ -10713,11 +10713,11 @@
           <a:p>
             <a:pPr>
               <a:spcAft>
-                <a:spcPts val="700"/>
+                <a:spcPts val="1400"/>
               </a:spcAft>
             </a:pPr>
             <a:r>
-              <a:rPr sz="1900">
+              <a:rPr sz="2100">
                 <a:solidFill>
                   <a:srgbClr val="333333"/>
                 </a:solidFill>
@@ -10728,11 +10728,11 @@
           <a:p>
             <a:pPr>
               <a:spcAft>
-                <a:spcPts val="700"/>
+                <a:spcPts val="1400"/>
               </a:spcAft>
             </a:pPr>
             <a:r>
-              <a:rPr sz="1700">
+              <a:rPr sz="1900">
                 <a:solidFill>
                   <a:srgbClr val="666666"/>
                 </a:solidFill>
@@ -10743,11 +10743,11 @@
           <a:p>
             <a:pPr>
               <a:spcAft>
-                <a:spcPts val="700"/>
+                <a:spcPts val="1400"/>
               </a:spcAft>
             </a:pPr>
             <a:r>
-              <a:rPr sz="1900">
+              <a:rPr sz="2100">
                 <a:solidFill>
                   <a:srgbClr val="333333"/>
                 </a:solidFill>
@@ -10758,11 +10758,11 @@
           <a:p>
             <a:pPr>
               <a:spcAft>
-                <a:spcPts val="700"/>
+                <a:spcPts val="1400"/>
               </a:spcAft>
             </a:pPr>
             <a:r>
-              <a:rPr sz="1900">
+              <a:rPr sz="2100">
                 <a:solidFill>
                   <a:srgbClr val="333333"/>
                 </a:solidFill>
@@ -10937,8 +10937,8 @@
         </p:nvSpPr>
         <p:spPr>
           <a:xfrm>
-            <a:off x="548640" y="1417320"/>
-            <a:ext cx="11094415" cy="4206240"/>
+            <a:off x="548640" y="2767965"/>
+            <a:ext cx="11094415" cy="3038474"/>
           </a:xfrm>
           <a:prstGeom prst="rect">
             <a:avLst/>
@@ -10953,11 +10953,11 @@
           <a:p>
             <a:pPr>
               <a:spcAft>
-                <a:spcPts val="700"/>
+                <a:spcPts val="1400"/>
               </a:spcAft>
             </a:pPr>
             <a:r>
-              <a:rPr sz="1900">
+              <a:rPr sz="2100">
                 <a:solidFill>
                   <a:srgbClr val="333333"/>
                 </a:solidFill>
@@ -10968,11 +10968,11 @@
           <a:p>
             <a:pPr>
               <a:spcAft>
-                <a:spcPts val="700"/>
+                <a:spcPts val="1400"/>
               </a:spcAft>
             </a:pPr>
             <a:r>
-              <a:rPr sz="1900">
+              <a:rPr sz="2100">
                 <a:solidFill>
                   <a:srgbClr val="333333"/>
                 </a:solidFill>
@@ -10983,11 +10983,11 @@
           <a:p>
             <a:pPr>
               <a:spcAft>
-                <a:spcPts val="700"/>
+                <a:spcPts val="1400"/>
               </a:spcAft>
             </a:pPr>
             <a:r>
-              <a:rPr sz="1900">
+              <a:rPr sz="2100">
                 <a:solidFill>
                   <a:srgbClr val="333333"/>
                 </a:solidFill>
@@ -11162,8 +11162,8 @@
         </p:nvSpPr>
         <p:spPr>
           <a:xfrm>
-            <a:off x="548640" y="1417320"/>
-            <a:ext cx="11094415" cy="4206240"/>
+            <a:off x="548640" y="2767965"/>
+            <a:ext cx="11094415" cy="3038474"/>
           </a:xfrm>
           <a:prstGeom prst="rect">
             <a:avLst/>
@@ -11178,11 +11178,11 @@
           <a:p>
             <a:pPr>
               <a:spcAft>
-                <a:spcPts val="700"/>
+                <a:spcPts val="1400"/>
               </a:spcAft>
             </a:pPr>
             <a:r>
-              <a:rPr sz="1900">
+              <a:rPr sz="2100">
                 <a:solidFill>
                   <a:srgbClr val="333333"/>
                 </a:solidFill>
@@ -11193,11 +11193,11 @@
           <a:p>
             <a:pPr>
               <a:spcAft>
-                <a:spcPts val="700"/>
+                <a:spcPts val="1400"/>
               </a:spcAft>
             </a:pPr>
             <a:r>
-              <a:rPr sz="1900">
+              <a:rPr sz="2100">
                 <a:solidFill>
                   <a:srgbClr val="333333"/>
                 </a:solidFill>
@@ -11208,11 +11208,11 @@
           <a:p>
             <a:pPr>
               <a:spcAft>
-                <a:spcPts val="700"/>
+                <a:spcPts val="1400"/>
               </a:spcAft>
             </a:pPr>
             <a:r>
-              <a:rPr sz="1900">
+              <a:rPr sz="2100">
                 <a:solidFill>
                   <a:srgbClr val="333333"/>
                 </a:solidFill>

</xml_diff>

<commit_message>
Add author credit (Sai Sanath Erram, Amrita Vishwa Vidyapeetham)
Credit the implementation/diagrams/deck author on the title slide (a bold
line directly under the paper authors) and on the closing Thanks slide,
phrased to stay distinct from the paper's authorship. Regenerate
RWE_talk.pptx / RWE_talk.pdf.

Co-Authored-By: Claude Opus 4.8 <noreply@anthropic.com>
Claude-Session: https://claude.ai/code/session_01DcTtyhsBxwWfFmVRuFUaej
</commit_message>
<xml_diff>
--- a/docs/RWE_talk.pptx
+++ b/docs/RWE_talk.pptx
@@ -5335,7 +5335,7 @@
         <p:spPr>
           <a:xfrm>
             <a:off x="822960" y="3840480"/>
-            <a:ext cx="10545775" cy="1828800"/>
+            <a:ext cx="10545775" cy="2103120"/>
           </a:xfrm>
           <a:prstGeom prst="rect">
             <a:avLst/>
@@ -5354,7 +5354,7 @@
               </a:spcAft>
             </a:pPr>
             <a:r>
-              <a:rPr sz="1800">
+              <a:rPr sz="1800" b="0">
                 <a:solidFill>
                   <a:srgbClr val="666666"/>
                 </a:solidFill>
@@ -5369,12 +5369,12 @@
               </a:spcAft>
             </a:pPr>
             <a:r>
-              <a:rPr sz="1600">
-                <a:solidFill>
-                  <a:srgbClr val="666666"/>
-                </a:solidFill>
-              </a:rPr>
-              <a:t>A slide-by-slide walkthrough mapped to this implementation.</a:t>
+              <a:rPr sz="1700" b="1">
+                <a:solidFill>
+                  <a:srgbClr val="333333"/>
+                </a:solidFill>
+              </a:rPr>
+              <a:t>Implementation, diagrams &amp; deck:  Sai Sanath Erram · Amrita Vishwa Vidyapeetham</a:t>
             </a:r>
           </a:p>
           <a:p>
@@ -5384,7 +5384,22 @@
               </a:spcAft>
             </a:pPr>
             <a:r>
-              <a:rPr sz="1300">
+              <a:rPr sz="1600" b="0">
+                <a:solidFill>
+                  <a:srgbClr val="666666"/>
+                </a:solidFill>
+              </a:rPr>
+              <a:t>A slide-by-slide walkthrough mapped to this implementation.</a:t>
+            </a:r>
+          </a:p>
+          <a:p>
+            <a:pPr>
+              <a:spcAft>
+                <a:spcPts val="600"/>
+              </a:spcAft>
+            </a:pPr>
+            <a:r>
+              <a:rPr sz="1300" b="0">
                 <a:solidFill>
                   <a:srgbClr val="CCCCCC"/>
                 </a:solidFill>
@@ -9650,7 +9665,7 @@
                   <a:srgbClr val="333333"/>
                 </a:solidFill>
               </a:rPr>
-              <a:t>•  This deck, diagrams and code-mapping: the implementation project.</a:t>
+              <a:t>•  Implementation &amp; deck: Sai Sanath Erram, Amrita Vishwa Vidyapeetham.</a:t>
             </a:r>
           </a:p>
         </p:txBody>

</xml_diff>

<commit_message>
Add author contact email to Thanks slide
Place erram.sanath@gmail.com as a contact line beneath the implementation
credit on the Thanks slide (all four elements don't fit one line at the
deck font size). Regenerate RWE_talk.pptx / RWE_talk.pdf.

Co-Authored-By: Claude Opus 4.8 <noreply@anthropic.com>
Claude-Session: https://claude.ai/code/session_01DcTtyhsBxwWfFmVRuFUaej
</commit_message>
<xml_diff>
--- a/docs/RWE_talk.pptx
+++ b/docs/RWE_talk.pptx
@@ -9610,8 +9610,8 @@
         </p:nvSpPr>
         <p:spPr>
           <a:xfrm>
-            <a:off x="548640" y="3042285"/>
-            <a:ext cx="11094415" cy="3312795"/>
+            <a:off x="548640" y="2753360"/>
+            <a:ext cx="11094415" cy="3601720"/>
           </a:xfrm>
           <a:prstGeom prst="rect">
             <a:avLst/>
@@ -9665,7 +9665,22 @@
                   <a:srgbClr val="333333"/>
                 </a:solidFill>
               </a:rPr>
-              <a:t>•  Implementation &amp; deck: Sai Sanath Erram, Amrita Vishwa Vidyapeetham.</a:t>
+              <a:t>•  Implementation &amp; deck: Sai Sanath Erram, Amrita Vishwa Vidyapeetham</a:t>
+            </a:r>
+          </a:p>
+          <a:p>
+            <a:pPr>
+              <a:spcAft>
+                <a:spcPts val="1400"/>
+              </a:spcAft>
+            </a:pPr>
+            <a:r>
+              <a:rPr sz="1900">
+                <a:solidFill>
+                  <a:srgbClr val="666666"/>
+                </a:solidFill>
+              </a:rPr>
+              <a:t>       –  erram.sanath@gmail.com</a:t>
             </a:r>
           </a:p>
         </p:txBody>

</xml_diff>